<commit_message>
Add thesis defence slide deck and its builder
- iut_submissions/presentation/Defence/: the defence presentation (24 content
  slides + references + closing), built from the finalized defence book.
- scripts/slides/build_defence_deck.py: regenerates the Defence .pptx from the
  base copy (native, editable shapes; IBM Plex fonts; ODC colour system);
  assets/methodology_diagram.png is the cropped four-RQ methodology diagram;
  open_deck.sh opens the deck in LibreOffice with the IBM Plex fonts.
- Pre-defence deck: OLD_ copy of the originally submitted .pptx added, and the
  team's modified pre-defence .pptx committed.
- .claude/settings.local.json: local Claude Code design-check hooks.

Co-Authored-By: Claude Opus 5 <noreply@anthropic.com>
</commit_message>
<xml_diff>
--- a/iut_submissions/presentation/SWE_Orthogonal Defect Classification on Defects4JUsing an LLM-Driven Scientific Approach_presentation.pptx
+++ b/iut_submissions/presentation/SWE_Orthogonal Defect Classification on Defects4JUsing an LLM-Driven Scientific Approach_presentation.pptx
@@ -64,7 +64,7 @@
         <a:srgbClr val="000000"/>
       </a:buClr>
       <a:buFont typeface="Arial"/>
-      <a:defRPr b="0" i="0" sz="1400" u="none" cap="none" strike="noStrike">
+      <a:defRPr b="0" i="0" spc="0" sz="1400" u="none" cap="none" strike="noStrike">
         <a:solidFill>
           <a:srgbClr val="000000"/>
         </a:solidFill>
@@ -88,7 +88,7 @@
         <a:srgbClr val="000000"/>
       </a:buClr>
       <a:buFont typeface="Arial"/>
-      <a:defRPr b="0" i="0" sz="1400" u="none" cap="none" strike="noStrike">
+      <a:defRPr b="0" i="0" spc="0" sz="1400" u="none" cap="none" strike="noStrike">
         <a:solidFill>
           <a:srgbClr val="000000"/>
         </a:solidFill>
@@ -112,7 +112,7 @@
         <a:srgbClr val="000000"/>
       </a:buClr>
       <a:buFont typeface="Arial"/>
-      <a:defRPr b="0" i="0" sz="1400" u="none" cap="none" strike="noStrike">
+      <a:defRPr b="0" i="0" spc="0" sz="1400" u="none" cap="none" strike="noStrike">
         <a:solidFill>
           <a:srgbClr val="000000"/>
         </a:solidFill>
@@ -136,7 +136,7 @@
         <a:srgbClr val="000000"/>
       </a:buClr>
       <a:buFont typeface="Arial"/>
-      <a:defRPr b="0" i="0" sz="1400" u="none" cap="none" strike="noStrike">
+      <a:defRPr b="0" i="0" spc="0" sz="1400" u="none" cap="none" strike="noStrike">
         <a:solidFill>
           <a:srgbClr val="000000"/>
         </a:solidFill>
@@ -160,7 +160,7 @@
         <a:srgbClr val="000000"/>
       </a:buClr>
       <a:buFont typeface="Arial"/>
-      <a:defRPr b="0" i="0" sz="1400" u="none" cap="none" strike="noStrike">
+      <a:defRPr b="0" i="0" spc="0" sz="1400" u="none" cap="none" strike="noStrike">
         <a:solidFill>
           <a:srgbClr val="000000"/>
         </a:solidFill>
@@ -184,7 +184,7 @@
         <a:srgbClr val="000000"/>
       </a:buClr>
       <a:buFont typeface="Arial"/>
-      <a:defRPr b="0" i="0" sz="1400" u="none" cap="none" strike="noStrike">
+      <a:defRPr b="0" i="0" spc="0" sz="1400" u="none" cap="none" strike="noStrike">
         <a:solidFill>
           <a:srgbClr val="000000"/>
         </a:solidFill>
@@ -208,7 +208,7 @@
         <a:srgbClr val="000000"/>
       </a:buClr>
       <a:buFont typeface="Arial"/>
-      <a:defRPr b="0" i="0" sz="1400" u="none" cap="none" strike="noStrike">
+      <a:defRPr b="0" i="0" spc="0" sz="1400" u="none" cap="none" strike="noStrike">
         <a:solidFill>
           <a:srgbClr val="000000"/>
         </a:solidFill>
@@ -232,7 +232,7 @@
         <a:srgbClr val="000000"/>
       </a:buClr>
       <a:buFont typeface="Arial"/>
-      <a:defRPr b="0" i="0" sz="1400" u="none" cap="none" strike="noStrike">
+      <a:defRPr b="0" i="0" spc="0" sz="1400" u="none" cap="none" strike="noStrike">
         <a:solidFill>
           <a:srgbClr val="000000"/>
         </a:solidFill>
@@ -256,7 +256,7 @@
         <a:srgbClr val="000000"/>
       </a:buClr>
       <a:buFont typeface="Arial"/>
-      <a:defRPr b="0" i="0" sz="1400" u="none" cap="none" strike="noStrike">
+      <a:defRPr b="0" i="0" spc="0" sz="1400" u="none" cap="none" strike="noStrike">
         <a:solidFill>
           <a:srgbClr val="000000"/>
         </a:solidFill>
@@ -506,7 +506,7 @@
         <a:srgbClr val="000000"/>
       </a:buClr>
       <a:buFont typeface="Arial"/>
-      <a:defRPr b="0" i="0" sz="1400" u="none" cap="none" strike="noStrike">
+      <a:defRPr b="0" i="0" spc="0" sz="1400" u="none" cap="none" strike="noStrike">
         <a:solidFill>
           <a:srgbClr val="000000"/>
         </a:solidFill>
@@ -530,7 +530,7 @@
         <a:srgbClr val="000000"/>
       </a:buClr>
       <a:buFont typeface="Arial"/>
-      <a:defRPr b="0" i="0" sz="1400" u="none" cap="none" strike="noStrike">
+      <a:defRPr b="0" i="0" spc="0" sz="1400" u="none" cap="none" strike="noStrike">
         <a:solidFill>
           <a:srgbClr val="000000"/>
         </a:solidFill>
@@ -554,7 +554,7 @@
         <a:srgbClr val="000000"/>
       </a:buClr>
       <a:buFont typeface="Arial"/>
-      <a:defRPr b="0" i="0" sz="1400" u="none" cap="none" strike="noStrike">
+      <a:defRPr b="0" i="0" spc="0" sz="1400" u="none" cap="none" strike="noStrike">
         <a:solidFill>
           <a:srgbClr val="000000"/>
         </a:solidFill>
@@ -578,7 +578,7 @@
         <a:srgbClr val="000000"/>
       </a:buClr>
       <a:buFont typeface="Arial"/>
-      <a:defRPr b="0" i="0" sz="1400" u="none" cap="none" strike="noStrike">
+      <a:defRPr b="0" i="0" spc="0" sz="1400" u="none" cap="none" strike="noStrike">
         <a:solidFill>
           <a:srgbClr val="000000"/>
         </a:solidFill>
@@ -602,7 +602,7 @@
         <a:srgbClr val="000000"/>
       </a:buClr>
       <a:buFont typeface="Arial"/>
-      <a:defRPr b="0" i="0" sz="1400" u="none" cap="none" strike="noStrike">
+      <a:defRPr b="0" i="0" spc="0" sz="1400" u="none" cap="none" strike="noStrike">
         <a:solidFill>
           <a:srgbClr val="000000"/>
         </a:solidFill>
@@ -626,7 +626,7 @@
         <a:srgbClr val="000000"/>
       </a:buClr>
       <a:buFont typeface="Arial"/>
-      <a:defRPr b="0" i="0" sz="1400" u="none" cap="none" strike="noStrike">
+      <a:defRPr b="0" i="0" spc="0" sz="1400" u="none" cap="none" strike="noStrike">
         <a:solidFill>
           <a:srgbClr val="000000"/>
         </a:solidFill>
@@ -650,7 +650,7 @@
         <a:srgbClr val="000000"/>
       </a:buClr>
       <a:buFont typeface="Arial"/>
-      <a:defRPr b="0" i="0" sz="1400" u="none" cap="none" strike="noStrike">
+      <a:defRPr b="0" i="0" spc="0" sz="1400" u="none" cap="none" strike="noStrike">
         <a:solidFill>
           <a:srgbClr val="000000"/>
         </a:solidFill>
@@ -674,7 +674,7 @@
         <a:srgbClr val="000000"/>
       </a:buClr>
       <a:buFont typeface="Arial"/>
-      <a:defRPr b="0" i="0" sz="1400" u="none" cap="none" strike="noStrike">
+      <a:defRPr b="0" i="0" spc="0" sz="1400" u="none" cap="none" strike="noStrike">
         <a:solidFill>
           <a:srgbClr val="000000"/>
         </a:solidFill>
@@ -698,7 +698,7 @@
         <a:srgbClr val="000000"/>
       </a:buClr>
       <a:buFont typeface="Arial"/>
-      <a:defRPr b="0" i="0" sz="1400" u="none" cap="none" strike="noStrike">
+      <a:defRPr b="0" i="0" spc="0" sz="1400" u="none" cap="none" strike="noStrike">
         <a:solidFill>
           <a:srgbClr val="000000"/>
         </a:solidFill>
@@ -12316,7 +12316,7 @@
           <a:srgbClr val="000000"/>
         </a:buClr>
         <a:buFont typeface="Arial"/>
-        <a:defRPr b="0" i="0" sz="1400" u="none" cap="none" strike="noStrike">
+        <a:defRPr b="0" i="0" spc="0" sz="1400" u="none" cap="none" strike="noStrike">
           <a:solidFill>
             <a:srgbClr val="000000"/>
           </a:solidFill>
@@ -12340,7 +12340,7 @@
           <a:srgbClr val="000000"/>
         </a:buClr>
         <a:buFont typeface="Arial"/>
-        <a:defRPr b="0" i="0" sz="1400" u="none" cap="none" strike="noStrike">
+        <a:defRPr b="0" i="0" spc="0" sz="1400" u="none" cap="none" strike="noStrike">
           <a:solidFill>
             <a:srgbClr val="000000"/>
           </a:solidFill>
@@ -12364,7 +12364,7 @@
           <a:srgbClr val="000000"/>
         </a:buClr>
         <a:buFont typeface="Arial"/>
-        <a:defRPr b="0" i="0" sz="1400" u="none" cap="none" strike="noStrike">
+        <a:defRPr b="0" i="0" spc="0" sz="1400" u="none" cap="none" strike="noStrike">
           <a:solidFill>
             <a:srgbClr val="000000"/>
           </a:solidFill>
@@ -12388,7 +12388,7 @@
           <a:srgbClr val="000000"/>
         </a:buClr>
         <a:buFont typeface="Arial"/>
-        <a:defRPr b="0" i="0" sz="1400" u="none" cap="none" strike="noStrike">
+        <a:defRPr b="0" i="0" spc="0" sz="1400" u="none" cap="none" strike="noStrike">
           <a:solidFill>
             <a:srgbClr val="000000"/>
           </a:solidFill>
@@ -12412,7 +12412,7 @@
           <a:srgbClr val="000000"/>
         </a:buClr>
         <a:buFont typeface="Arial"/>
-        <a:defRPr b="0" i="0" sz="1400" u="none" cap="none" strike="noStrike">
+        <a:defRPr b="0" i="0" spc="0" sz="1400" u="none" cap="none" strike="noStrike">
           <a:solidFill>
             <a:srgbClr val="000000"/>
           </a:solidFill>
@@ -12436,7 +12436,7 @@
           <a:srgbClr val="000000"/>
         </a:buClr>
         <a:buFont typeface="Arial"/>
-        <a:defRPr b="0" i="0" sz="1400" u="none" cap="none" strike="noStrike">
+        <a:defRPr b="0" i="0" spc="0" sz="1400" u="none" cap="none" strike="noStrike">
           <a:solidFill>
             <a:srgbClr val="000000"/>
           </a:solidFill>
@@ -12460,7 +12460,7 @@
           <a:srgbClr val="000000"/>
         </a:buClr>
         <a:buFont typeface="Arial"/>
-        <a:defRPr b="0" i="0" sz="1400" u="none" cap="none" strike="noStrike">
+        <a:defRPr b="0" i="0" spc="0" sz="1400" u="none" cap="none" strike="noStrike">
           <a:solidFill>
             <a:srgbClr val="000000"/>
           </a:solidFill>
@@ -12484,7 +12484,7 @@
           <a:srgbClr val="000000"/>
         </a:buClr>
         <a:buFont typeface="Arial"/>
-        <a:defRPr b="0" i="0" sz="1400" u="none" cap="none" strike="noStrike">
+        <a:defRPr b="0" i="0" spc="0" sz="1400" u="none" cap="none" strike="noStrike">
           <a:solidFill>
             <a:srgbClr val="000000"/>
           </a:solidFill>
@@ -12508,7 +12508,7 @@
           <a:srgbClr val="000000"/>
         </a:buClr>
         <a:buFont typeface="Arial"/>
-        <a:defRPr b="0" i="0" sz="1400" u="none" cap="none" strike="noStrike">
+        <a:defRPr b="0" i="0" spc="0" sz="1400" u="none" cap="none" strike="noStrike">
           <a:solidFill>
             <a:srgbClr val="000000"/>
           </a:solidFill>
@@ -12545,7 +12545,7 @@
           <a:srgbClr val="000000"/>
         </a:buClr>
         <a:buFont typeface="Arial"/>
-        <a:defRPr b="0" i="0" sz="1400" u="none" cap="none" strike="noStrike">
+        <a:defRPr b="0" i="0" spc="0" sz="1400" u="none" cap="none" strike="noStrike">
           <a:solidFill>
             <a:srgbClr val="000000"/>
           </a:solidFill>
@@ -12569,7 +12569,7 @@
           <a:srgbClr val="000000"/>
         </a:buClr>
         <a:buFont typeface="Arial"/>
-        <a:defRPr b="0" i="0" sz="1400" u="none" cap="none" strike="noStrike">
+        <a:defRPr b="0" i="0" spc="0" sz="1400" u="none" cap="none" strike="noStrike">
           <a:solidFill>
             <a:srgbClr val="000000"/>
           </a:solidFill>
@@ -12593,7 +12593,7 @@
           <a:srgbClr val="000000"/>
         </a:buClr>
         <a:buFont typeface="Arial"/>
-        <a:defRPr b="0" i="0" sz="1400" u="none" cap="none" strike="noStrike">
+        <a:defRPr b="0" i="0" spc="0" sz="1400" u="none" cap="none" strike="noStrike">
           <a:solidFill>
             <a:srgbClr val="000000"/>
           </a:solidFill>
@@ -12617,7 +12617,7 @@
           <a:srgbClr val="000000"/>
         </a:buClr>
         <a:buFont typeface="Arial"/>
-        <a:defRPr b="0" i="0" sz="1400" u="none" cap="none" strike="noStrike">
+        <a:defRPr b="0" i="0" spc="0" sz="1400" u="none" cap="none" strike="noStrike">
           <a:solidFill>
             <a:srgbClr val="000000"/>
           </a:solidFill>
@@ -12641,7 +12641,7 @@
           <a:srgbClr val="000000"/>
         </a:buClr>
         <a:buFont typeface="Arial"/>
-        <a:defRPr b="0" i="0" sz="1400" u="none" cap="none" strike="noStrike">
+        <a:defRPr b="0" i="0" spc="0" sz="1400" u="none" cap="none" strike="noStrike">
           <a:solidFill>
             <a:srgbClr val="000000"/>
           </a:solidFill>
@@ -12665,7 +12665,7 @@
           <a:srgbClr val="000000"/>
         </a:buClr>
         <a:buFont typeface="Arial"/>
-        <a:defRPr b="0" i="0" sz="1400" u="none" cap="none" strike="noStrike">
+        <a:defRPr b="0" i="0" spc="0" sz="1400" u="none" cap="none" strike="noStrike">
           <a:solidFill>
             <a:srgbClr val="000000"/>
           </a:solidFill>
@@ -12689,7 +12689,7 @@
           <a:srgbClr val="000000"/>
         </a:buClr>
         <a:buFont typeface="Arial"/>
-        <a:defRPr b="0" i="0" sz="1400" u="none" cap="none" strike="noStrike">
+        <a:defRPr b="0" i="0" spc="0" sz="1400" u="none" cap="none" strike="noStrike">
           <a:solidFill>
             <a:srgbClr val="000000"/>
           </a:solidFill>
@@ -12713,7 +12713,7 @@
           <a:srgbClr val="000000"/>
         </a:buClr>
         <a:buFont typeface="Arial"/>
-        <a:defRPr b="0" i="0" sz="1400" u="none" cap="none" strike="noStrike">
+        <a:defRPr b="0" i="0" spc="0" sz="1400" u="none" cap="none" strike="noStrike">
           <a:solidFill>
             <a:srgbClr val="000000"/>
           </a:solidFill>
@@ -12737,7 +12737,7 @@
           <a:srgbClr val="000000"/>
         </a:buClr>
         <a:buFont typeface="Arial"/>
-        <a:defRPr b="0" i="0" sz="1400" u="none" cap="none" strike="noStrike">
+        <a:defRPr b="0" i="0" spc="0" sz="1400" u="none" cap="none" strike="noStrike">
           <a:solidFill>
             <a:srgbClr val="000000"/>
           </a:solidFill>
@@ -12774,7 +12774,7 @@
           <a:srgbClr val="000000"/>
         </a:buClr>
         <a:buFont typeface="Arial"/>
-        <a:defRPr b="0" i="0" sz="1400" u="none" cap="none" strike="noStrike">
+        <a:defRPr b="0" i="0" spc="0" sz="1400" u="none" cap="none" strike="noStrike">
           <a:solidFill>
             <a:srgbClr val="000000"/>
           </a:solidFill>
@@ -12798,7 +12798,7 @@
           <a:srgbClr val="000000"/>
         </a:buClr>
         <a:buFont typeface="Arial"/>
-        <a:defRPr b="0" i="0" sz="1400" u="none" cap="none" strike="noStrike">
+        <a:defRPr b="0" i="0" spc="0" sz="1400" u="none" cap="none" strike="noStrike">
           <a:solidFill>
             <a:srgbClr val="000000"/>
           </a:solidFill>
@@ -12822,7 +12822,7 @@
           <a:srgbClr val="000000"/>
         </a:buClr>
         <a:buFont typeface="Arial"/>
-        <a:defRPr b="0" i="0" sz="1400" u="none" cap="none" strike="noStrike">
+        <a:defRPr b="0" i="0" spc="0" sz="1400" u="none" cap="none" strike="noStrike">
           <a:solidFill>
             <a:srgbClr val="000000"/>
           </a:solidFill>
@@ -12846,7 +12846,7 @@
           <a:srgbClr val="000000"/>
         </a:buClr>
         <a:buFont typeface="Arial"/>
-        <a:defRPr b="0" i="0" sz="1400" u="none" cap="none" strike="noStrike">
+        <a:defRPr b="0" i="0" spc="0" sz="1400" u="none" cap="none" strike="noStrike">
           <a:solidFill>
             <a:srgbClr val="000000"/>
           </a:solidFill>
@@ -12870,7 +12870,7 @@
           <a:srgbClr val="000000"/>
         </a:buClr>
         <a:buFont typeface="Arial"/>
-        <a:defRPr b="0" i="0" sz="1400" u="none" cap="none" strike="noStrike">
+        <a:defRPr b="0" i="0" spc="0" sz="1400" u="none" cap="none" strike="noStrike">
           <a:solidFill>
             <a:srgbClr val="000000"/>
           </a:solidFill>
@@ -12894,7 +12894,7 @@
           <a:srgbClr val="000000"/>
         </a:buClr>
         <a:buFont typeface="Arial"/>
-        <a:defRPr b="0" i="0" sz="1400" u="none" cap="none" strike="noStrike">
+        <a:defRPr b="0" i="0" spc="0" sz="1400" u="none" cap="none" strike="noStrike">
           <a:solidFill>
             <a:srgbClr val="000000"/>
           </a:solidFill>
@@ -12918,7 +12918,7 @@
           <a:srgbClr val="000000"/>
         </a:buClr>
         <a:buFont typeface="Arial"/>
-        <a:defRPr b="0" i="0" sz="1400" u="none" cap="none" strike="noStrike">
+        <a:defRPr b="0" i="0" spc="0" sz="1400" u="none" cap="none" strike="noStrike">
           <a:solidFill>
             <a:srgbClr val="000000"/>
           </a:solidFill>
@@ -12942,7 +12942,7 @@
           <a:srgbClr val="000000"/>
         </a:buClr>
         <a:buFont typeface="Arial"/>
-        <a:defRPr b="0" i="0" sz="1400" u="none" cap="none" strike="noStrike">
+        <a:defRPr b="0" i="0" spc="0" sz="1400" u="none" cap="none" strike="noStrike">
           <a:solidFill>
             <a:srgbClr val="000000"/>
           </a:solidFill>
@@ -12966,7 +12966,7 @@
           <a:srgbClr val="000000"/>
         </a:buClr>
         <a:buFont typeface="Arial"/>
-        <a:defRPr b="0" i="0" sz="1400" u="none" cap="none" strike="noStrike">
+        <a:defRPr b="0" i="0" spc="0" sz="1400" u="none" cap="none" strike="noStrike">
           <a:solidFill>
             <a:srgbClr val="000000"/>
           </a:solidFill>
@@ -13028,7 +13028,7 @@
           <a:effectLst>
             <a:outerShdw blurRad="40000" rotWithShape="0" dir="5400000" dist="23000">
               <a:srgbClr val="000000">
-                <a:alpha val="34901"/>
+                <a:alpha val="34902"/>
               </a:srgbClr>
             </a:outerShdw>
           </a:effectLst>
@@ -13140,7 +13140,7 @@
           <a:effectLst>
             <a:outerShdw blurRad="40000" rotWithShape="0" dir="5400000" dist="23000">
               <a:srgbClr val="000000">
-                <a:alpha val="34901"/>
+                <a:alpha val="34902"/>
               </a:srgbClr>
             </a:outerShdw>
           </a:effectLst>
@@ -13334,7 +13334,7 @@
           <a:effectLst>
             <a:outerShdw blurRad="40000" rotWithShape="0" dir="5400000" dist="23000">
               <a:srgbClr val="000000">
-                <a:alpha val="34901"/>
+                <a:alpha val="34902"/>
               </a:srgbClr>
             </a:outerShdw>
           </a:effectLst>
@@ -13830,7 +13830,7 @@
           <a:effectLst>
             <a:outerShdw blurRad="40000" rotWithShape="0" dir="5400000" dist="23000">
               <a:srgbClr val="000000">
-                <a:alpha val="34901"/>
+                <a:alpha val="34902"/>
               </a:srgbClr>
             </a:outerShdw>
           </a:effectLst>
@@ -13888,7 +13888,7 @@
           <a:effectLst>
             <a:outerShdw blurRad="40000" rotWithShape="0" dir="5400000" dist="23000">
               <a:srgbClr val="000000">
-                <a:alpha val="34901"/>
+                <a:alpha val="34902"/>
               </a:srgbClr>
             </a:outerShdw>
           </a:effectLst>
@@ -13948,7 +13948,7 @@
           <a:effectLst>
             <a:outerShdw blurRad="40000" rotWithShape="0" dir="5400000" dist="23000">
               <a:srgbClr val="000000">
-                <a:alpha val="34901"/>
+                <a:alpha val="34902"/>
               </a:srgbClr>
             </a:outerShdw>
           </a:effectLst>
@@ -14159,7 +14159,7 @@
           <a:effectLst>
             <a:outerShdw blurRad="40000" rotWithShape="0" dir="5400000" dist="23000">
               <a:srgbClr val="000000">
-                <a:alpha val="34901"/>
+                <a:alpha val="34902"/>
               </a:srgbClr>
             </a:outerShdw>
           </a:effectLst>
@@ -14470,7 +14470,7 @@
           <a:effectLst>
             <a:outerShdw blurRad="40000" rotWithShape="0" dir="5400000" dist="23000">
               <a:srgbClr val="000000">
-                <a:alpha val="34901"/>
+                <a:alpha val="34902"/>
               </a:srgbClr>
             </a:outerShdw>
           </a:effectLst>
@@ -15065,7 +15065,7 @@
           <a:effectLst>
             <a:outerShdw blurRad="40000" rotWithShape="0" dir="5400000" dist="23000">
               <a:srgbClr val="000000">
-                <a:alpha val="34901"/>
+                <a:alpha val="34902"/>
               </a:srgbClr>
             </a:outerShdw>
           </a:effectLst>
@@ -15123,7 +15123,7 @@
           <a:effectLst>
             <a:outerShdw blurRad="40000" rotWithShape="0" dir="5400000" dist="23000">
               <a:srgbClr val="000000">
-                <a:alpha val="34901"/>
+                <a:alpha val="34902"/>
               </a:srgbClr>
             </a:outerShdw>
           </a:effectLst>
@@ -16794,7 +16794,7 @@
           <a:effectLst>
             <a:outerShdw blurRad="40000" rotWithShape="0" dir="5400000" dist="23000">
               <a:srgbClr val="000000">
-                <a:alpha val="34901"/>
+                <a:alpha val="34902"/>
               </a:srgbClr>
             </a:outerShdw>
           </a:effectLst>
@@ -16852,7 +16852,7 @@
           <a:effectLst>
             <a:outerShdw blurRad="40000" rotWithShape="0" dir="5400000" dist="23000">
               <a:srgbClr val="000000">
-                <a:alpha val="34901"/>
+                <a:alpha val="34902"/>
               </a:srgbClr>
             </a:outerShdw>
           </a:effectLst>
@@ -16912,7 +16912,7 @@
           <a:effectLst>
             <a:outerShdw blurRad="40000" rotWithShape="0" dir="5400000" dist="23000">
               <a:srgbClr val="000000">
-                <a:alpha val="34901"/>
+                <a:alpha val="34902"/>
               </a:srgbClr>
             </a:outerShdw>
           </a:effectLst>
@@ -17003,7 +17003,7 @@
           <a:effectLst>
             <a:outerShdw blurRad="40000" rotWithShape="0" dir="5400000" dist="23000">
               <a:srgbClr val="000000">
-                <a:alpha val="34901"/>
+                <a:alpha val="34902"/>
               </a:srgbClr>
             </a:outerShdw>
           </a:effectLst>
@@ -17072,7 +17072,7 @@
           <a:effectLst>
             <a:outerShdw blurRad="40000" rotWithShape="0" dir="5400000" dist="23000">
               <a:srgbClr val="000000">
-                <a:alpha val="34901"/>
+                <a:alpha val="34902"/>
               </a:srgbClr>
             </a:outerShdw>
           </a:effectLst>
@@ -17163,7 +17163,7 @@
           <a:effectLst>
             <a:outerShdw blurRad="40000" rotWithShape="0" dir="5400000" dist="23000">
               <a:srgbClr val="000000">
-                <a:alpha val="34901"/>
+                <a:alpha val="34902"/>
               </a:srgbClr>
             </a:outerShdw>
           </a:effectLst>
@@ -17232,7 +17232,7 @@
           <a:effectLst>
             <a:outerShdw blurRad="40000" rotWithShape="0" dir="5400000" dist="23000">
               <a:srgbClr val="000000">
-                <a:alpha val="34901"/>
+                <a:alpha val="34902"/>
               </a:srgbClr>
             </a:outerShdw>
           </a:effectLst>
@@ -17323,7 +17323,7 @@
           <a:effectLst>
             <a:outerShdw blurRad="40000" rotWithShape="0" dir="5400000" dist="23000">
               <a:srgbClr val="000000">
-                <a:alpha val="34901"/>
+                <a:alpha val="34902"/>
               </a:srgbClr>
             </a:outerShdw>
           </a:effectLst>
@@ -17392,7 +17392,7 @@
           <a:effectLst>
             <a:outerShdw blurRad="40000" rotWithShape="0" dir="5400000" dist="23000">
               <a:srgbClr val="000000">
-                <a:alpha val="34901"/>
+                <a:alpha val="34902"/>
               </a:srgbClr>
             </a:outerShdw>
           </a:effectLst>
@@ -17483,7 +17483,7 @@
           <a:effectLst>
             <a:outerShdw blurRad="40000" rotWithShape="0" dir="5400000" dist="23000">
               <a:srgbClr val="000000">
-                <a:alpha val="34901"/>
+                <a:alpha val="34902"/>
               </a:srgbClr>
             </a:outerShdw>
           </a:effectLst>
@@ -17736,7 +17736,7 @@
           <a:effectLst>
             <a:outerShdw blurRad="40000" rotWithShape="0" dir="5400000" dist="23000">
               <a:srgbClr val="000000">
-                <a:alpha val="34901"/>
+                <a:alpha val="34902"/>
               </a:srgbClr>
             </a:outerShdw>
           </a:effectLst>
@@ -17794,7 +17794,7 @@
           <a:effectLst>
             <a:outerShdw blurRad="40000" rotWithShape="0" dir="5400000" dist="23000">
               <a:srgbClr val="000000">
-                <a:alpha val="34901"/>
+                <a:alpha val="34902"/>
               </a:srgbClr>
             </a:outerShdw>
           </a:effectLst>
@@ -17860,7 +17860,7 @@
           <a:effectLst>
             <a:outerShdw blurRad="40000" rotWithShape="0" dir="5400000" dist="23000">
               <a:srgbClr val="000000">
-                <a:alpha val="34901"/>
+                <a:alpha val="34902"/>
               </a:srgbClr>
             </a:outerShdw>
           </a:effectLst>
@@ -17920,7 +17920,7 @@
           <a:effectLst>
             <a:outerShdw blurRad="40000" rotWithShape="0" dir="5400000" dist="23000">
               <a:srgbClr val="000000">
-                <a:alpha val="34901"/>
+                <a:alpha val="34902"/>
               </a:srgbClr>
             </a:outerShdw>
           </a:effectLst>
@@ -18133,7 +18133,7 @@
           <a:effectLst>
             <a:outerShdw blurRad="40000" rotWithShape="0" dir="5400000" dist="23000">
               <a:srgbClr val="000000">
-                <a:alpha val="34901"/>
+                <a:alpha val="34902"/>
               </a:srgbClr>
             </a:outerShdw>
           </a:effectLst>
@@ -18193,7 +18193,7 @@
           <a:effectLst>
             <a:outerShdw blurRad="40000" rotWithShape="0" dir="5400000" dist="23000">
               <a:srgbClr val="000000">
-                <a:alpha val="34901"/>
+                <a:alpha val="34902"/>
               </a:srgbClr>
             </a:outerShdw>
           </a:effectLst>
@@ -18406,7 +18406,7 @@
           <a:effectLst>
             <a:outerShdw blurRad="40000" rotWithShape="0" dir="5400000" dist="23000">
               <a:srgbClr val="000000">
-                <a:alpha val="34901"/>
+                <a:alpha val="34902"/>
               </a:srgbClr>
             </a:outerShdw>
           </a:effectLst>
@@ -18466,7 +18466,7 @@
           <a:effectLst>
             <a:outerShdw blurRad="40000" rotWithShape="0" dir="5400000" dist="23000">
               <a:srgbClr val="000000">
-                <a:alpha val="34901"/>
+                <a:alpha val="34902"/>
               </a:srgbClr>
             </a:outerShdw>
           </a:effectLst>
@@ -18779,7 +18779,7 @@
           <a:effectLst>
             <a:outerShdw blurRad="40000" rotWithShape="0" dir="5400000" dist="23000">
               <a:srgbClr val="000000">
-                <a:alpha val="34901"/>
+                <a:alpha val="34902"/>
               </a:srgbClr>
             </a:outerShdw>
           </a:effectLst>
@@ -19156,7 +19156,7 @@
           <a:effectLst>
             <a:outerShdw blurRad="40000" rotWithShape="0" dir="5400000" dist="23000">
               <a:srgbClr val="000000">
-                <a:alpha val="34901"/>
+                <a:alpha val="34902"/>
               </a:srgbClr>
             </a:outerShdw>
           </a:effectLst>
@@ -19214,7 +19214,7 @@
           <a:effectLst>
             <a:outerShdw blurRad="40000" rotWithShape="0" dir="5400000" dist="23000">
               <a:srgbClr val="000000">
-                <a:alpha val="34901"/>
+                <a:alpha val="34902"/>
               </a:srgbClr>
             </a:outerShdw>
           </a:effectLst>
@@ -19272,7 +19272,7 @@
           <a:effectLst>
             <a:outerShdw blurRad="40000" rotWithShape="0" dir="5400000" dist="23000">
               <a:srgbClr val="000000">
-                <a:alpha val="34901"/>
+                <a:alpha val="34902"/>
               </a:srgbClr>
             </a:outerShdw>
           </a:effectLst>
@@ -19431,7 +19431,7 @@
           <a:effectLst>
             <a:outerShdw blurRad="40000" rotWithShape="0" dir="5400000" dist="23000">
               <a:srgbClr val="000000">
-                <a:alpha val="34901"/>
+                <a:alpha val="34902"/>
               </a:srgbClr>
             </a:outerShdw>
           </a:effectLst>
@@ -19590,7 +19590,7 @@
           <a:effectLst>
             <a:outerShdw blurRad="40000" rotWithShape="0" dir="5400000" dist="23000">
               <a:srgbClr val="000000">
-                <a:alpha val="34901"/>
+                <a:alpha val="34902"/>
               </a:srgbClr>
             </a:outerShdw>
           </a:effectLst>
@@ -19749,7 +19749,7 @@
           <a:effectLst>
             <a:outerShdw blurRad="40000" rotWithShape="0" dir="5400000" dist="23000">
               <a:srgbClr val="000000">
-                <a:alpha val="34901"/>
+                <a:alpha val="34902"/>
               </a:srgbClr>
             </a:outerShdw>
           </a:effectLst>
@@ -19908,7 +19908,7 @@
           <a:effectLst>
             <a:outerShdw blurRad="40000" rotWithShape="0" dir="5400000" dist="23000">
               <a:srgbClr val="000000">
-                <a:alpha val="34901"/>
+                <a:alpha val="34902"/>
               </a:srgbClr>
             </a:outerShdw>
           </a:effectLst>
@@ -20067,7 +20067,7 @@
           <a:effectLst>
             <a:outerShdw blurRad="40000" rotWithShape="0" dir="5400000" dist="23000">
               <a:srgbClr val="000000">
-                <a:alpha val="34901"/>
+                <a:alpha val="34902"/>
               </a:srgbClr>
             </a:outerShdw>
           </a:effectLst>
@@ -20226,7 +20226,7 @@
           <a:effectLst>
             <a:outerShdw blurRad="40000" rotWithShape="0" dir="5400000" dist="23000">
               <a:srgbClr val="000000">
-                <a:alpha val="34901"/>
+                <a:alpha val="34902"/>
               </a:srgbClr>
             </a:outerShdw>
           </a:effectLst>
@@ -20385,7 +20385,7 @@
           <a:effectLst>
             <a:outerShdw blurRad="40000" rotWithShape="0" dir="5400000" dist="23000">
               <a:srgbClr val="000000">
-                <a:alpha val="34901"/>
+                <a:alpha val="34902"/>
               </a:srgbClr>
             </a:outerShdw>
           </a:effectLst>
@@ -20730,7 +20730,7 @@
           <a:effectLst>
             <a:outerShdw blurRad="40000" rotWithShape="0" dir="5400000" dist="23000">
               <a:srgbClr val="000000">
-                <a:alpha val="34901"/>
+                <a:alpha val="34902"/>
               </a:srgbClr>
             </a:outerShdw>
           </a:effectLst>
@@ -20788,7 +20788,7 @@
           <a:effectLst>
             <a:outerShdw blurRad="40000" rotWithShape="0" dir="5400000" dist="23000">
               <a:srgbClr val="000000">
-                <a:alpha val="34901"/>
+                <a:alpha val="34902"/>
               </a:srgbClr>
             </a:outerShdw>
           </a:effectLst>
@@ -20854,7 +20854,7 @@
           <a:effectLst>
             <a:outerShdw blurRad="40000" rotWithShape="0" dir="5400000" dist="23000">
               <a:srgbClr val="000000">
-                <a:alpha val="34901"/>
+                <a:alpha val="34902"/>
               </a:srgbClr>
             </a:outerShdw>
           </a:effectLst>
@@ -20914,7 +20914,7 @@
           <a:effectLst>
             <a:outerShdw blurRad="40000" rotWithShape="0" dir="5400000" dist="23000">
               <a:srgbClr val="000000">
-                <a:alpha val="34901"/>
+                <a:alpha val="34902"/>
               </a:srgbClr>
             </a:outerShdw>
           </a:effectLst>
@@ -20981,7 +20981,7 @@
           <a:effectLst>
             <a:outerShdw blurRad="40000" rotWithShape="0" dir="5400000" dist="23000">
               <a:srgbClr val="000000">
-                <a:alpha val="34901"/>
+                <a:alpha val="34902"/>
               </a:srgbClr>
             </a:outerShdw>
           </a:effectLst>
@@ -21041,7 +21041,7 @@
           <a:effectLst>
             <a:outerShdw blurRad="40000" rotWithShape="0" dir="5400000" dist="23000">
               <a:srgbClr val="000000">
-                <a:alpha val="34901"/>
+                <a:alpha val="34902"/>
               </a:srgbClr>
             </a:outerShdw>
           </a:effectLst>
@@ -21108,7 +21108,7 @@
           <a:effectLst>
             <a:outerShdw blurRad="40000" rotWithShape="0" dir="5400000" dist="23000">
               <a:srgbClr val="000000">
-                <a:alpha val="34901"/>
+                <a:alpha val="34902"/>
               </a:srgbClr>
             </a:outerShdw>
           </a:effectLst>
@@ -22009,7 +22009,7 @@
           <a:effectLst>
             <a:outerShdw blurRad="40000" rotWithShape="0" dir="5400000" dist="23000">
               <a:srgbClr val="000000">
-                <a:alpha val="34901"/>
+                <a:alpha val="34902"/>
               </a:srgbClr>
             </a:outerShdw>
           </a:effectLst>
@@ -22067,7 +22067,7 @@
           <a:effectLst>
             <a:outerShdw blurRad="40000" rotWithShape="0" dir="5400000" dist="23000">
               <a:srgbClr val="000000">
-                <a:alpha val="34901"/>
+                <a:alpha val="34902"/>
               </a:srgbClr>
             </a:outerShdw>
           </a:effectLst>
@@ -23207,7 +23207,7 @@
           <a:effectLst>
             <a:outerShdw blurRad="40000" rotWithShape="0" dir="5400000" dist="23000">
               <a:srgbClr val="000000">
-                <a:alpha val="34901"/>
+                <a:alpha val="34902"/>
               </a:srgbClr>
             </a:outerShdw>
           </a:effectLst>
@@ -23265,7 +23265,7 @@
           <a:effectLst>
             <a:outerShdw blurRad="40000" rotWithShape="0" dir="5400000" dist="23000">
               <a:srgbClr val="000000">
-                <a:alpha val="34901"/>
+                <a:alpha val="34902"/>
               </a:srgbClr>
             </a:outerShdw>
           </a:effectLst>
@@ -25186,7 +25186,7 @@
           <a:effectLst>
             <a:outerShdw blurRad="40000" rotWithShape="0" dir="5400000" dist="23000">
               <a:srgbClr val="000000">
-                <a:alpha val="34901"/>
+                <a:alpha val="34902"/>
               </a:srgbClr>
             </a:outerShdw>
           </a:effectLst>
@@ -25244,7 +25244,7 @@
           <a:effectLst>
             <a:outerShdw blurRad="40000" rotWithShape="0" dir="5400000" dist="23000">
               <a:srgbClr val="000000">
-                <a:alpha val="34901"/>
+                <a:alpha val="34902"/>
               </a:srgbClr>
             </a:outerShdw>
           </a:effectLst>
@@ -27073,7 +27073,7 @@
           <a:effectLst>
             <a:outerShdw blurRad="40000" rotWithShape="0" dir="5400000" dist="23000">
               <a:srgbClr val="000000">
-                <a:alpha val="34901"/>
+                <a:alpha val="34902"/>
               </a:srgbClr>
             </a:outerShdw>
           </a:effectLst>
@@ -27131,7 +27131,7 @@
           <a:effectLst>
             <a:outerShdw blurRad="40000" rotWithShape="0" dir="5400000" dist="23000">
               <a:srgbClr val="000000">
-                <a:alpha val="34901"/>
+                <a:alpha val="34902"/>
               </a:srgbClr>
             </a:outerShdw>
           </a:effectLst>
@@ -27251,7 +27251,7 @@
           <a:effectLst>
             <a:outerShdw blurRad="40000" rotWithShape="0" dir="5400000" dist="23000">
               <a:srgbClr val="000000">
-                <a:alpha val="34901"/>
+                <a:alpha val="34902"/>
               </a:srgbClr>
             </a:outerShdw>
           </a:effectLst>
@@ -27390,7 +27390,7 @@
           <a:effectLst>
             <a:outerShdw blurRad="40000" rotWithShape="0" dir="5400000" dist="23000">
               <a:srgbClr val="000000">
-                <a:alpha val="34901"/>
+                <a:alpha val="34902"/>
               </a:srgbClr>
             </a:outerShdw>
           </a:effectLst>
@@ -27529,7 +27529,7 @@
           <a:effectLst>
             <a:outerShdw blurRad="40000" rotWithShape="0" dir="5400000" dist="23000">
               <a:srgbClr val="000000">
-                <a:alpha val="34901"/>
+                <a:alpha val="34902"/>
               </a:srgbClr>
             </a:outerShdw>
           </a:effectLst>
@@ -27668,7 +27668,7 @@
           <a:effectLst>
             <a:outerShdw blurRad="40000" rotWithShape="0" dir="5400000" dist="23000">
               <a:srgbClr val="000000">
-                <a:alpha val="34901"/>
+                <a:alpha val="34902"/>
               </a:srgbClr>
             </a:outerShdw>
           </a:effectLst>
@@ -28092,7 +28092,7 @@
           <a:effectLst>
             <a:outerShdw blurRad="40000" rotWithShape="0" dir="5400000" dist="23000">
               <a:srgbClr val="000000">
-                <a:alpha val="34901"/>
+                <a:alpha val="34902"/>
               </a:srgbClr>
             </a:outerShdw>
           </a:effectLst>
@@ -28150,7 +28150,7 @@
           <a:effectLst>
             <a:outerShdw blurRad="40000" rotWithShape="0" dir="5400000" dist="23000">
               <a:srgbClr val="000000">
-                <a:alpha val="34901"/>
+                <a:alpha val="34902"/>
               </a:srgbClr>
             </a:outerShdw>
           </a:effectLst>
@@ -28262,7 +28262,7 @@
           <a:effectLst>
             <a:outerShdw blurRad="40000" rotWithShape="0" dir="5400000" dist="23000">
               <a:srgbClr val="000000">
-                <a:alpha val="34901"/>
+                <a:alpha val="34902"/>
               </a:srgbClr>
             </a:outerShdw>
           </a:effectLst>
@@ -28421,7 +28421,7 @@
           <a:effectLst>
             <a:outerShdw blurRad="40000" rotWithShape="0" dir="5400000" dist="23000">
               <a:srgbClr val="000000">
-                <a:alpha val="34901"/>
+                <a:alpha val="34902"/>
               </a:srgbClr>
             </a:outerShdw>
           </a:effectLst>
@@ -28580,7 +28580,7 @@
           <a:effectLst>
             <a:outerShdw blurRad="40000" rotWithShape="0" dir="5400000" dist="23000">
               <a:srgbClr val="000000">
-                <a:alpha val="34901"/>
+                <a:alpha val="34902"/>
               </a:srgbClr>
             </a:outerShdw>
           </a:effectLst>
@@ -28739,7 +28739,7 @@
           <a:effectLst>
             <a:outerShdw blurRad="40000" rotWithShape="0" dir="5400000" dist="23000">
               <a:srgbClr val="000000">
-                <a:alpha val="34901"/>
+                <a:alpha val="34902"/>
               </a:srgbClr>
             </a:outerShdw>
           </a:effectLst>
@@ -28898,7 +28898,7 @@
           <a:effectLst>
             <a:outerShdw blurRad="40000" rotWithShape="0" dir="5400000" dist="23000">
               <a:srgbClr val="000000">
-                <a:alpha val="34901"/>
+                <a:alpha val="34902"/>
               </a:srgbClr>
             </a:outerShdw>
           </a:effectLst>
@@ -29057,7 +29057,7 @@
           <a:effectLst>
             <a:outerShdw blurRad="40000" rotWithShape="0" dir="5400000" dist="23000">
               <a:srgbClr val="000000">
-                <a:alpha val="34901"/>
+                <a:alpha val="34902"/>
               </a:srgbClr>
             </a:outerShdw>
           </a:effectLst>
@@ -29224,7 +29224,7 @@
           <a:effectLst>
             <a:outerShdw blurRad="40000" rotWithShape="0" dir="5400000" dist="23000">
               <a:srgbClr val="000000">
-                <a:alpha val="34901"/>
+                <a:alpha val="34902"/>
               </a:srgbClr>
             </a:outerShdw>
           </a:effectLst>
@@ -29407,7 +29407,7 @@
           <a:effectLst>
             <a:outerShdw blurRad="40000" rotWithShape="0" dir="5400000" dist="23000">
               <a:srgbClr val="000000">
-                <a:alpha val="34901"/>
+                <a:alpha val="34902"/>
               </a:srgbClr>
             </a:outerShdw>
           </a:effectLst>
@@ -29566,7 +29566,7 @@
           <a:effectLst>
             <a:outerShdw blurRad="40000" rotWithShape="0" dir="5400000" dist="23000">
               <a:srgbClr val="000000">
-                <a:alpha val="34901"/>
+                <a:alpha val="34902"/>
               </a:srgbClr>
             </a:outerShdw>
           </a:effectLst>
@@ -29725,7 +29725,7 @@
           <a:effectLst>
             <a:outerShdw blurRad="40000" rotWithShape="0" dir="5400000" dist="23000">
               <a:srgbClr val="000000">
-                <a:alpha val="34901"/>
+                <a:alpha val="34902"/>
               </a:srgbClr>
             </a:outerShdw>
           </a:effectLst>
@@ -32646,7 +32646,7 @@
           <a:effectLst>
             <a:outerShdw blurRad="40000" rotWithShape="0" dir="5400000" dist="23000">
               <a:srgbClr val="000000">
-                <a:alpha val="34901"/>
+                <a:alpha val="34902"/>
               </a:srgbClr>
             </a:outerShdw>
           </a:effectLst>
@@ -32704,7 +32704,7 @@
           <a:effectLst>
             <a:outerShdw blurRad="40000" rotWithShape="0" dir="5400000" dist="23000">
               <a:srgbClr val="000000">
-                <a:alpha val="34901"/>
+                <a:alpha val="34902"/>
               </a:srgbClr>
             </a:outerShdw>
           </a:effectLst>
@@ -33494,7 +33494,7 @@
           <a:effectLst>
             <a:outerShdw blurRad="40000" rotWithShape="0" dir="5400000" dist="23000">
               <a:srgbClr val="000000">
-                <a:alpha val="34901"/>
+                <a:alpha val="34902"/>
               </a:srgbClr>
             </a:outerShdw>
           </a:effectLst>
@@ -33552,7 +33552,7 @@
           <a:effectLst>
             <a:outerShdw blurRad="40000" rotWithShape="0" dir="5400000" dist="23000">
               <a:srgbClr val="000000">
-                <a:alpha val="34901"/>
+                <a:alpha val="34902"/>
               </a:srgbClr>
             </a:outerShdw>
           </a:effectLst>
@@ -33612,7 +33612,7 @@
           <a:effectLst>
             <a:outerShdw blurRad="40000" rotWithShape="0" dir="5400000" dist="23000">
               <a:srgbClr val="000000">
-                <a:alpha val="34901"/>
+                <a:alpha val="34902"/>
               </a:srgbClr>
             </a:outerShdw>
           </a:effectLst>
@@ -33697,7 +33697,7 @@
           <a:effectLst>
             <a:outerShdw blurRad="40000" rotWithShape="0" dir="5400000" dist="23000">
               <a:srgbClr val="000000">
-                <a:alpha val="34901"/>
+                <a:alpha val="34902"/>
               </a:srgbClr>
             </a:outerShdw>
           </a:effectLst>
@@ -33782,7 +33782,7 @@
           <a:effectLst>
             <a:outerShdw blurRad="40000" rotWithShape="0" dir="5400000" dist="23000">
               <a:srgbClr val="000000">
-                <a:alpha val="34901"/>
+                <a:alpha val="34902"/>
               </a:srgbClr>
             </a:outerShdw>
           </a:effectLst>
@@ -33867,7 +33867,7 @@
           <a:effectLst>
             <a:outerShdw blurRad="40000" rotWithShape="0" dir="5400000" dist="23000">
               <a:srgbClr val="000000">
-                <a:alpha val="34901"/>
+                <a:alpha val="34902"/>
               </a:srgbClr>
             </a:outerShdw>
           </a:effectLst>
@@ -33952,7 +33952,7 @@
           <a:effectLst>
             <a:outerShdw blurRad="40000" rotWithShape="0" dir="5400000" dist="23000">
               <a:srgbClr val="000000">
-                <a:alpha val="34901"/>
+                <a:alpha val="34902"/>
               </a:srgbClr>
             </a:outerShdw>
           </a:effectLst>
@@ -34721,7 +34721,7 @@
           <a:effectLst>
             <a:outerShdw blurRad="40000" rotWithShape="0" dir="5400000" dist="23000">
               <a:srgbClr val="000000">
-                <a:alpha val="34901"/>
+                <a:alpha val="34902"/>
               </a:srgbClr>
             </a:outerShdw>
           </a:effectLst>
@@ -34779,7 +34779,7 @@
           <a:effectLst>
             <a:outerShdw blurRad="40000" rotWithShape="0" dir="5400000" dist="23000">
               <a:srgbClr val="000000">
-                <a:alpha val="34901"/>
+                <a:alpha val="34902"/>
               </a:srgbClr>
             </a:outerShdw>
           </a:effectLst>
@@ -34837,7 +34837,7 @@
           <a:effectLst>
             <a:outerShdw blurRad="40000" rotWithShape="0" dir="5400000" dist="23000">
               <a:srgbClr val="000000">
-                <a:alpha val="34901"/>
+                <a:alpha val="34902"/>
               </a:srgbClr>
             </a:outerShdw>
           </a:effectLst>
@@ -34895,7 +34895,7 @@
           <a:effectLst>
             <a:outerShdw blurRad="40000" rotWithShape="0" dir="5400000" dist="23000">
               <a:srgbClr val="000000">
-                <a:alpha val="34901"/>
+                <a:alpha val="34902"/>
               </a:srgbClr>
             </a:outerShdw>
           </a:effectLst>
@@ -34953,7 +34953,7 @@
           <a:effectLst>
             <a:outerShdw blurRad="40000" rotWithShape="0" dir="5400000" dist="23000">
               <a:srgbClr val="000000">
-                <a:alpha val="34901"/>
+                <a:alpha val="34902"/>
               </a:srgbClr>
             </a:outerShdw>
           </a:effectLst>
@@ -35011,7 +35011,7 @@
           <a:effectLst>
             <a:outerShdw blurRad="40000" rotWithShape="0" dir="5400000" dist="23000">
               <a:srgbClr val="000000">
-                <a:alpha val="34901"/>
+                <a:alpha val="34902"/>
               </a:srgbClr>
             </a:outerShdw>
           </a:effectLst>
@@ -35069,7 +35069,7 @@
           <a:effectLst>
             <a:outerShdw blurRad="40000" rotWithShape="0" dir="5400000" dist="23000">
               <a:srgbClr val="000000">
-                <a:alpha val="34901"/>
+                <a:alpha val="34902"/>
               </a:srgbClr>
             </a:outerShdw>
           </a:effectLst>
@@ -35849,7 +35849,7 @@
           <a:effectLst>
             <a:outerShdw blurRad="40000" rotWithShape="0" dir="5400000" dist="23000">
               <a:srgbClr val="000000">
-                <a:alpha val="34901"/>
+                <a:alpha val="34902"/>
               </a:srgbClr>
             </a:outerShdw>
           </a:effectLst>
@@ -35907,7 +35907,7 @@
           <a:effectLst>
             <a:outerShdw blurRad="40000" rotWithShape="0" dir="5400000" dist="23000">
               <a:srgbClr val="000000">
-                <a:alpha val="34901"/>
+                <a:alpha val="34902"/>
               </a:srgbClr>
             </a:outerShdw>
           </a:effectLst>
@@ -36537,7 +36537,7 @@
           <a:effectLst>
             <a:outerShdw blurRad="40000" rotWithShape="0" dir="5400000" dist="23000">
               <a:srgbClr val="000000">
-                <a:alpha val="34901"/>
+                <a:alpha val="34902"/>
               </a:srgbClr>
             </a:outerShdw>
           </a:effectLst>
@@ -36595,7 +36595,7 @@
           <a:effectLst>
             <a:outerShdw blurRad="40000" rotWithShape="0" dir="5400000" dist="23000">
               <a:srgbClr val="000000">
-                <a:alpha val="34901"/>
+                <a:alpha val="34902"/>
               </a:srgbClr>
             </a:outerShdw>
           </a:effectLst>
@@ -37293,7 +37293,7 @@
           <a:effectLst>
             <a:outerShdw blurRad="40000" rotWithShape="0" dir="5400000" dist="23000">
               <a:srgbClr val="000000">
-                <a:alpha val="34901"/>
+                <a:alpha val="34902"/>
               </a:srgbClr>
             </a:outerShdw>
           </a:effectLst>
@@ -37351,7 +37351,7 @@
           <a:effectLst>
             <a:outerShdw blurRad="40000" rotWithShape="0" dir="5400000" dist="23000">
               <a:srgbClr val="000000">
-                <a:alpha val="34901"/>
+                <a:alpha val="34902"/>
               </a:srgbClr>
             </a:outerShdw>
           </a:effectLst>
@@ -37778,7 +37778,7 @@
           <a:effectLst>
             <a:outerShdw blurRad="40000" rotWithShape="0" dir="5400000" dist="23000">
               <a:srgbClr val="000000">
-                <a:alpha val="34901"/>
+                <a:alpha val="34902"/>
               </a:srgbClr>
             </a:outerShdw>
           </a:effectLst>
@@ -38407,7 +38407,7 @@
           <a:effectLst>
             <a:outerShdw blurRad="40000" rotWithShape="0" dir="5400000" dist="23000">
               <a:srgbClr val="000000">
-                <a:alpha val="34901"/>
+                <a:alpha val="34902"/>
               </a:srgbClr>
             </a:outerShdw>
           </a:effectLst>
@@ -38465,7 +38465,7 @@
           <a:effectLst>
             <a:outerShdw blurRad="40000" rotWithShape="0" dir="5400000" dist="23000">
               <a:srgbClr val="000000">
-                <a:alpha val="34901"/>
+                <a:alpha val="34902"/>
               </a:srgbClr>
             </a:outerShdw>
           </a:effectLst>
@@ -38790,7 +38790,7 @@
           <a:effectLst>
             <a:outerShdw blurRad="40000" rotWithShape="0" dir="5400000" dist="23000">
               <a:srgbClr val="000000">
-                <a:alpha val="34901"/>
+                <a:alpha val="34902"/>
               </a:srgbClr>
             </a:outerShdw>
           </a:effectLst>
@@ -38849,7 +38849,7 @@
           <a:effectLst>
             <a:outerShdw blurRad="40000" rotWithShape="0" dir="5400000" dist="23000">
               <a:srgbClr val="000000">
-                <a:alpha val="34901"/>
+                <a:alpha val="34902"/>
               </a:srgbClr>
             </a:outerShdw>
           </a:effectLst>
@@ -38909,7 +38909,7 @@
           <a:effectLst>
             <a:outerShdw blurRad="40000" rotWithShape="0" dir="5400000" dist="23000">
               <a:srgbClr val="000000">
-                <a:alpha val="34901"/>
+                <a:alpha val="34902"/>
               </a:srgbClr>
             </a:outerShdw>
           </a:effectLst>
@@ -38968,7 +38968,7 @@
           <a:effectLst>
             <a:outerShdw blurRad="40000" rotWithShape="0" dir="5400000" dist="23000">
               <a:srgbClr val="000000">
-                <a:alpha val="34901"/>
+                <a:alpha val="34902"/>
               </a:srgbClr>
             </a:outerShdw>
           </a:effectLst>
@@ -39028,7 +39028,7 @@
           <a:effectLst>
             <a:outerShdw blurRad="40000" rotWithShape="0" dir="5400000" dist="23000">
               <a:srgbClr val="000000">
-                <a:alpha val="34901"/>
+                <a:alpha val="34902"/>
               </a:srgbClr>
             </a:outerShdw>
           </a:effectLst>
@@ -39087,7 +39087,7 @@
           <a:effectLst>
             <a:outerShdw blurRad="40000" rotWithShape="0" dir="5400000" dist="23000">
               <a:srgbClr val="000000">
-                <a:alpha val="34901"/>
+                <a:alpha val="34902"/>
               </a:srgbClr>
             </a:outerShdw>
           </a:effectLst>
@@ -39147,7 +39147,7 @@
           <a:effectLst>
             <a:outerShdw blurRad="40000" rotWithShape="0" dir="5400000" dist="23000">
               <a:srgbClr val="000000">
-                <a:alpha val="34901"/>
+                <a:alpha val="34902"/>
               </a:srgbClr>
             </a:outerShdw>
           </a:effectLst>
@@ -39206,7 +39206,7 @@
           <a:effectLst>
             <a:outerShdw blurRad="40000" rotWithShape="0" dir="5400000" dist="23000">
               <a:srgbClr val="000000">
-                <a:alpha val="34901"/>
+                <a:alpha val="34902"/>
               </a:srgbClr>
             </a:outerShdw>
           </a:effectLst>
@@ -39266,7 +39266,7 @@
           <a:effectLst>
             <a:outerShdw blurRad="40000" rotWithShape="0" dir="5400000" dist="23000">
               <a:srgbClr val="000000">
-                <a:alpha val="34901"/>
+                <a:alpha val="34902"/>
               </a:srgbClr>
             </a:outerShdw>
           </a:effectLst>
@@ -39333,7 +39333,7 @@
           <a:effectLst>
             <a:outerShdw blurRad="40000" rotWithShape="0" dir="5400000" dist="23000">
               <a:srgbClr val="000000">
-                <a:alpha val="34901"/>
+                <a:alpha val="34902"/>
               </a:srgbClr>
             </a:outerShdw>
           </a:effectLst>
@@ -39602,7 +39602,7 @@
           <a:effectLst>
             <a:outerShdw blurRad="40000" rotWithShape="0" dir="5400000" dist="23000">
               <a:srgbClr val="000000">
-                <a:alpha val="34901"/>
+                <a:alpha val="34902"/>
               </a:srgbClr>
             </a:outerShdw>
           </a:effectLst>
@@ -39660,7 +39660,7 @@
           <a:effectLst>
             <a:outerShdw blurRad="40000" rotWithShape="0" dir="5400000" dist="23000">
               <a:srgbClr val="000000">
-                <a:alpha val="34901"/>
+                <a:alpha val="34902"/>
               </a:srgbClr>
             </a:outerShdw>
           </a:effectLst>
@@ -39720,7 +39720,7 @@
           <a:effectLst>
             <a:outerShdw blurRad="40000" rotWithShape="0" dir="5400000" dist="23000">
               <a:srgbClr val="000000">
-                <a:alpha val="34901"/>
+                <a:alpha val="34902"/>
               </a:srgbClr>
             </a:outerShdw>
           </a:effectLst>
@@ -39953,7 +39953,7 @@
           <a:effectLst>
             <a:outerShdw blurRad="40000" rotWithShape="0" dir="5400000" dist="23000">
               <a:srgbClr val="000000">
-                <a:alpha val="34901"/>
+                <a:alpha val="34902"/>
               </a:srgbClr>
             </a:outerShdw>
           </a:effectLst>
@@ -40186,7 +40186,7 @@
           <a:effectLst>
             <a:outerShdw blurRad="40000" rotWithShape="0" dir="5400000" dist="23000">
               <a:srgbClr val="000000">
-                <a:alpha val="34901"/>
+                <a:alpha val="34902"/>
               </a:srgbClr>
             </a:outerShdw>
           </a:effectLst>
@@ -40437,7 +40437,7 @@
           <a:effectLst>
             <a:outerShdw blurRad="40000" rotWithShape="0" dir="5400000" dist="23000">
               <a:srgbClr val="000000">
-                <a:alpha val="34901"/>
+                <a:alpha val="34902"/>
               </a:srgbClr>
             </a:outerShdw>
           </a:effectLst>
@@ -40682,7 +40682,7 @@
           <a:effectLst>
             <a:outerShdw blurRad="40000" rotWithShape="0" dir="5400000" dist="23000">
               <a:srgbClr val="000000">
-                <a:alpha val="34901"/>
+                <a:alpha val="34902"/>
               </a:srgbClr>
             </a:outerShdw>
           </a:effectLst>
@@ -40740,7 +40740,7 @@
           <a:effectLst>
             <a:outerShdw blurRad="40000" rotWithShape="0" dir="5400000" dist="23000">
               <a:srgbClr val="000000">
-                <a:alpha val="34901"/>
+                <a:alpha val="34902"/>
               </a:srgbClr>
             </a:outerShdw>
           </a:effectLst>
@@ -41418,7 +41418,7 @@
           <a:effectLst>
             <a:outerShdw blurRad="40000" rotWithShape="0" dir="5400000" dist="23000">
               <a:srgbClr val="000000">
-                <a:alpha val="34901"/>
+                <a:alpha val="34902"/>
               </a:srgbClr>
             </a:outerShdw>
           </a:effectLst>
@@ -41476,7 +41476,7 @@
           <a:effectLst>
             <a:outerShdw blurRad="40000" rotWithShape="0" dir="5400000" dist="23000">
               <a:srgbClr val="000000">
-                <a:alpha val="34901"/>
+                <a:alpha val="34902"/>
               </a:srgbClr>
             </a:outerShdw>
           </a:effectLst>
@@ -41784,7 +41784,7 @@
           <a:effectLst>
             <a:outerShdw blurRad="40000" rotWithShape="0" dir="5400000" dist="23000">
               <a:srgbClr val="000000">
-                <a:alpha val="34901"/>
+                <a:alpha val="34902"/>
               </a:srgbClr>
             </a:outerShdw>
           </a:effectLst>
@@ -42964,7 +42964,7 @@
           <a:effectLst>
             <a:outerShdw blurRad="40000" rotWithShape="0" dir="5400000" dist="23000">
               <a:srgbClr val="000000">
-                <a:alpha val="34901"/>
+                <a:alpha val="34902"/>
               </a:srgbClr>
             </a:outerShdw>
           </a:effectLst>
@@ -43022,7 +43022,7 @@
           <a:effectLst>
             <a:outerShdw blurRad="40000" rotWithShape="0" dir="5400000" dist="23000">
               <a:srgbClr val="000000">
-                <a:alpha val="34901"/>
+                <a:alpha val="34902"/>
               </a:srgbClr>
             </a:outerShdw>
           </a:effectLst>

</xml_diff>